<commit_message>
Ajustar créditos de cursos 4 y 5 al estilo final de los cursos 1-3
Co-Authored-By: Claude Opus 5.5 <noreply@anthropic.com>
Claude-Session: https://claude.ai/code/session_01ECfkxKzanoc9tBzEYwq5z6
</commit_message>
<xml_diff>
--- a/entregas/creditos_cursos_4_5/C4_M1_01_Ficha_laboratorio_IA_PDF_interactivo_COMPLETO_con_creditos.pptx
+++ b/entregas/creditos_cursos_4_5/C4_M1_01_Ficha_laboratorio_IA_PDF_interactivo_COMPLETO_con_creditos.pptx
@@ -7735,7 +7735,7 @@
                           </a:solidFill>
                           <a:latin typeface="Arial"/>
                         </a:rPr>
-                        <a:t>Coordinación general</a:t>
+                        <a:t>Coordinación general:</a:t>
                       </a:r>
                     </a:p>
                   </a:txBody>
@@ -7831,7 +7831,7 @@
                           </a:solidFill>
                           <a:latin typeface="Arial"/>
                         </a:rPr>
-                        <a:t>Experto temático</a:t>
+                        <a:t>Experto temático:</a:t>
                       </a:r>
                     </a:p>
                   </a:txBody>
@@ -7927,7 +7927,7 @@
                           </a:solidFill>
                           <a:latin typeface="Arial"/>
                         </a:rPr>
-                        <a:t>Diseñador de la experiencia virtual de aprendizaje</a:t>
+                        <a:t>Diseñador de la experiencia virtual de aprendizaje:</a:t>
                       </a:r>
                     </a:p>
                   </a:txBody>
@@ -8023,7 +8023,7 @@
                           </a:solidFill>
                           <a:latin typeface="Arial"/>
                         </a:rPr>
-                        <a:t>Corrección de estilo</a:t>
+                        <a:t>Corrección de estilo:</a:t>
                       </a:r>
                     </a:p>
                   </a:txBody>
@@ -8119,7 +8119,7 @@
                           </a:solidFill>
                           <a:latin typeface="Arial"/>
                         </a:rPr>
-                        <a:t>Validación pedagógica</a:t>
+                        <a:t>Validación pedagógica:</a:t>
                       </a:r>
                     </a:p>
                   </a:txBody>
@@ -8215,7 +8215,7 @@
                           </a:solidFill>
                           <a:latin typeface="Arial"/>
                         </a:rPr>
-                        <a:t>Diseño gráfico</a:t>
+                        <a:t>Diseño gráfico:</a:t>
                       </a:r>
                     </a:p>
                   </a:txBody>
@@ -8311,7 +8311,7 @@
                           </a:solidFill>
                           <a:latin typeface="Arial"/>
                         </a:rPr>
-                        <a:t>Desarrollo multimedia e interactivos</a:t>
+                        <a:t>Desarrollo de interactivos:</a:t>
                       </a:r>
                     </a:p>
                   </a:txBody>
@@ -8407,7 +8407,7 @@
                           </a:solidFill>
                           <a:latin typeface="Arial"/>
                         </a:rPr>
-                        <a:t>Disposición y ensamble</a:t>
+                        <a:t>Disposición y ensamble:</a:t>
                       </a:r>
                     </a:p>
                   </a:txBody>

</xml_diff>